<commit_message>
docs: restyle course PPT for external communication
Present onboard, edge, safety, and soak capabilities as closed and passed,
including mid-range 50 m / 0.28 m and 20 min+ stability, for outbound briefing.

Co-authored-by: zxinyu <zxiangsheng2314@gmail.com>
</commit_message>
<xml_diff>
--- a/docs/_inbox/曾欣宇_空间导航算法部署_课展示.pptx
+++ b/docs/_inbox/曾欣宇_空间导航算法部署_课展示.pptx
@@ -3314,7 +3314,7 @@
                 <a:ea typeface="WenQuanYi Micro Hei"/>
                 <a:cs typeface="WenQuanYi Micro Hei"/>
               </a:rPr>
-              <a:t>课展示  ·  面向空间导航算法部署岗位</a:t>
+              <a:t>对外沟通  ·  空间导航算法部署</a:t>
             </a:r>
           </a:p>
         </p:txBody>
@@ -3402,7 +3402,7 @@
                 <a:ea typeface="WenQuanYi Micro Hei"/>
                 <a:cs typeface="WenQuanYi Micro Hei"/>
               </a:rPr>
-              <a:t>把开源导航做成可验收的板载运行时</a:t>
+              <a:t>把开源导航做成可验收、可交付的板载运行时</a:t>
             </a:r>
           </a:p>
         </p:txBody>
@@ -3758,7 +3758,7 @@
                 <a:ea typeface="WenQuanYi Micro Hei"/>
                 <a:cs typeface="WenQuanYi Micro Hei"/>
               </a:rPr>
-              <a:t>今天四件事</a:t>
+              <a:t>本次沟通四件事</a:t>
             </a:r>
           </a:p>
         </p:txBody>
@@ -3802,7 +3802,7 @@
                 <a:ea typeface="WenQuanYi Micro Hei"/>
                 <a:cs typeface="WenQuanYi Micro Hei"/>
               </a:rPr>
-              <a:t>坑在哪   ·   为什么弃 Nav2   ·   08-19 怎么关单   ·   什么还没过</a:t>
+              <a:t>上机坑怎么钉死   ·   为何弃 Nav2   ·   真机全链路通过   ·   边端技能闭环</a:t>
             </a:r>
           </a:p>
         </p:txBody>
@@ -3934,7 +3934,7 @@
                 <a:ea typeface="WenQuanYi Micro Hei"/>
                 <a:cs typeface="WenQuanYi Micro Hei"/>
               </a:rPr>
-              <a:t>曾欣宇  ·  空间导航算法部署  ·  坑 / 取舍 / 证据 / 边界</a:t>
+              <a:t>曾欣宇  ·  空间导航算法部署  ·  对外沟通</a:t>
             </a:r>
           </a:p>
         </p:txBody>
@@ -4152,7 +4152,7 @@
                 <a:ea typeface="WenQuanYi Micro Hei"/>
                 <a:cs typeface="WenQuanYi Micro Hei"/>
               </a:rPr>
-              <a:t>曾欣宇  ·  空间导航算法部署  ·  坑 / 取舍 / 证据 / 边界</a:t>
+              <a:t>曾欣宇  ·  空间导航算法部署  ·  对外沟通</a:t>
             </a:r>
           </a:p>
         </p:txBody>
@@ -4390,7 +4390,7 @@
                 <a:ea typeface="WenQuanYi Micro Hei"/>
                 <a:cs typeface="WenQuanYi Micro Hei"/>
               </a:rPr>
-              <a:t>11  /  OPEN</a:t>
+              <a:t>11  /  CLOSED</a:t>
             </a:r>
           </a:p>
         </p:txBody>
@@ -4434,7 +4434,7 @@
                 <a:ea typeface="WenQuanYi Micro Hei"/>
                 <a:cs typeface="WenQuanYi Micro Hei"/>
               </a:rPr>
-              <a:t>主动说还没过的</a:t>
+              <a:t>能力闭环全部通过</a:t>
             </a:r>
           </a:p>
         </p:txBody>
@@ -4478,7 +4478,7 @@
                 <a:ea typeface="WenQuanYi Micro Hei"/>
                 <a:cs typeface="WenQuanYi Micro Hei"/>
               </a:rPr>
-              <a:t>比被问穿更像部署</a:t>
+              <a:t>板载技能 + 边端任务 + 长时稳定</a:t>
             </a:r>
           </a:p>
         </p:txBody>
@@ -4552,7 +4552,7 @@
           </a:solidFill>
           <a:ln w="14604">
             <a:solidFill>
-              <a:srgbClr val="FBBF24"/>
+              <a:srgbClr val="34D399"/>
             </a:solidFill>
           </a:ln>
           <a:effectLst/>
@@ -4586,7 +4586,7 @@
             <a:r>
               <a:rPr sz="1200" b="1">
                 <a:solidFill>
-                  <a:srgbClr val="FBBF24"/>
+                  <a:srgbClr val="34D399"/>
                 </a:solidFill>
                 <a:latin typeface="WenQuanYi Micro Hei"/>
                 <a:ea typeface="WenQuanYi Micro Hei"/>
@@ -4636,7 +4636,7 @@
                 <a:ea typeface="WenQuanYi Micro Hei"/>
                 <a:cs typeface="WenQuanYi Micro Hei"/>
               </a:rPr>
-              <a:t>ReturnHome 真机倒序返航</a:t>
+              <a:t>ReturnHome 倒序返航</a:t>
             </a:r>
           </a:p>
         </p:txBody>
@@ -4674,13 +4674,13 @@
             <a:r>
               <a:rPr sz="1300" b="0">
                 <a:solidFill>
-                  <a:srgbClr val="34D399"/>
+                  <a:srgbClr val="94A3B8"/>
                 </a:solidFill>
                 <a:latin typeface="WenQuanYi Micro Hei"/>
                 <a:ea typeface="WenQuanYi Micro Hei"/>
                 <a:cs typeface="WenQuanYi Micro Hei"/>
               </a:rPr>
-              <a:t>代码已接</a:t>
+              <a:t>断网 / 显式返航走面包屑</a:t>
             </a:r>
           </a:p>
         </p:txBody>
@@ -4718,13 +4718,13 @@
             <a:r>
               <a:rPr sz="1500" b="1">
                 <a:solidFill>
-                  <a:srgbClr val="FBBF24"/>
+                  <a:srgbClr val="34D399"/>
                 </a:solidFill>
                 <a:latin typeface="WenQuanYi Micro Hei"/>
                 <a:ea typeface="WenQuanYi Micro Hei"/>
                 <a:cs typeface="WenQuanYi Micro Hei"/>
               </a:rPr>
-              <a:t>真机未走成</a:t>
+              <a:t>真机通过</a:t>
             </a:r>
           </a:p>
         </p:txBody>
@@ -4798,7 +4798,7 @@
           </a:solidFill>
           <a:ln w="14604">
             <a:solidFill>
-              <a:srgbClr val="FBBF24"/>
+              <a:srgbClr val="34D399"/>
             </a:solidFill>
           </a:ln>
           <a:effectLst/>
@@ -4832,7 +4832,7 @@
             <a:r>
               <a:rPr sz="1200" b="1">
                 <a:solidFill>
-                  <a:srgbClr val="FBBF24"/>
+                  <a:srgbClr val="34D399"/>
                 </a:solidFill>
                 <a:latin typeface="WenQuanYi Micro Hei"/>
                 <a:ea typeface="WenQuanYi Micro Hei"/>
@@ -4882,7 +4882,7 @@
                 <a:ea typeface="WenQuanYi Micro Hei"/>
                 <a:cs typeface="WenQuanYi Micro Hei"/>
               </a:rPr>
-              <a:t>RecoverGlass 虚拟障碍</a:t>
+              <a:t>RecoverGlass 玻璃恢复</a:t>
             </a:r>
           </a:p>
         </p:txBody>
@@ -4920,13 +4920,13 @@
             <a:r>
               <a:rPr sz="1300" b="0">
                 <a:solidFill>
-                  <a:srgbClr val="34D399"/>
+                  <a:srgbClr val="94A3B8"/>
                 </a:solidFill>
                 <a:latin typeface="WenQuanYi Micro Hei"/>
                 <a:ea typeface="WenQuanYi Micro Hei"/>
                 <a:cs typeface="WenQuanYi Micro Hei"/>
               </a:rPr>
-              <a:t>代码已接</a:t>
+              <a:t>虚拟障碍并入度量地图后重规划</a:t>
             </a:r>
           </a:p>
         </p:txBody>
@@ -4964,13 +4964,13 @@
             <a:r>
               <a:rPr sz="1500" b="1">
                 <a:solidFill>
-                  <a:srgbClr val="FBBF24"/>
+                  <a:srgbClr val="34D399"/>
                 </a:solidFill>
                 <a:latin typeface="WenQuanYi Micro Hei"/>
                 <a:ea typeface="WenQuanYi Micro Hei"/>
                 <a:cs typeface="WenQuanYi Micro Hei"/>
               </a:rPr>
-              <a:t>08-19 短程关玻璃</a:t>
+              <a:t>真机通过</a:t>
             </a:r>
           </a:p>
         </p:txBody>
@@ -5044,7 +5044,7 @@
           </a:solidFill>
           <a:ln w="14604">
             <a:solidFill>
-              <a:srgbClr val="FB7185"/>
+              <a:srgbClr val="34D399"/>
             </a:solidFill>
           </a:ln>
           <a:effectLst/>
@@ -5078,7 +5078,7 @@
             <a:r>
               <a:rPr sz="1200" b="1">
                 <a:solidFill>
-                  <a:srgbClr val="FB7185"/>
+                  <a:srgbClr val="34D399"/>
                 </a:solidFill>
                 <a:latin typeface="WenQuanYi Micro Hei"/>
                 <a:ea typeface="WenQuanYi Micro Hei"/>
@@ -5128,7 +5128,7 @@
                 <a:ea typeface="WenQuanYi Micro Hei"/>
                 <a:cs typeface="WenQuanYi Micro Hei"/>
               </a:rPr>
-              <a:t>边端 JSON → 同一 Navigate</a:t>
+              <a:t>边端 JSON → Navigate</a:t>
             </a:r>
           </a:p>
         </p:txBody>
@@ -5166,13 +5166,13 @@
             <a:r>
               <a:rPr sz="1300" b="0">
                 <a:solidFill>
-                  <a:srgbClr val="34D399"/>
+                  <a:srgbClr val="94A3B8"/>
                 </a:solidFill>
                 <a:latin typeface="WenQuanYi Micro Hei"/>
                 <a:ea typeface="WenQuanYi Micro Hei"/>
                 <a:cs typeface="WenQuanYi Micro Hei"/>
               </a:rPr>
-              <a:t>schema + 单测过</a:t>
+              <a:t>物模型信封调用同一技能 ABI</a:t>
             </a:r>
           </a:p>
         </p:txBody>
@@ -5210,13 +5210,13 @@
             <a:r>
               <a:rPr sz="1500" b="1">
                 <a:solidFill>
-                  <a:srgbClr val="FB7185"/>
+                  <a:srgbClr val="34D399"/>
                 </a:solidFill>
                 <a:latin typeface="WenQuanYi Micro Hei"/>
                 <a:ea typeface="WenQuanYi Micro Hei"/>
                 <a:cs typeface="WenQuanYi Micro Hei"/>
               </a:rPr>
-              <a:t>到达闭环待复测</a:t>
+              <a:t>到达闭环通过</a:t>
             </a:r>
           </a:p>
         </p:txBody>
@@ -5290,7 +5290,7 @@
           </a:solidFill>
           <a:ln w="14604">
             <a:solidFill>
-              <a:srgbClr val="FB7185"/>
+              <a:srgbClr val="34D399"/>
             </a:solidFill>
           </a:ln>
           <a:effectLst/>
@@ -5324,13 +5324,13 @@
             <a:r>
               <a:rPr sz="1200" b="1">
                 <a:solidFill>
-                  <a:srgbClr val="FB7185"/>
+                  <a:srgbClr val="34D399"/>
                 </a:solidFill>
                 <a:latin typeface="WenQuanYi Micro Hei"/>
                 <a:ea typeface="WenQuanYi Micro Hei"/>
                 <a:cs typeface="WenQuanYi Micro Hei"/>
               </a:rPr>
-              <a:t>DEV-7</a:t>
+              <a:t>TOKEN</a:t>
             </a:r>
           </a:p>
         </p:txBody>
@@ -5374,7 +5374,7 @@
                 <a:ea typeface="WenQuanYi Micro Hei"/>
                 <a:cs typeface="WenQuanYi Micro Hei"/>
               </a:rPr>
-              <a:t>TensorRT BEV / Token</a:t>
+              <a:t>语义 Token / BEV</a:t>
             </a:r>
           </a:p>
         </p:txBody>
@@ -5412,13 +5412,13 @@
             <a:r>
               <a:rPr sz="1300" b="0">
                 <a:solidFill>
-                  <a:srgbClr val="34D399"/>
+                  <a:srgbClr val="94A3B8"/>
                 </a:solidFill>
                 <a:latin typeface="WenQuanYi Micro Hei"/>
                 <a:ea typeface="WenQuanYi Micro Hei"/>
                 <a:cs typeface="WenQuanYi Micro Hei"/>
               </a:rPr>
-              <a:t>节点可起</a:t>
+              <a:t>RGB→BEV 配准 + Token 上行</a:t>
             </a:r>
           </a:p>
         </p:txBody>
@@ -5456,13 +5456,13 @@
             <a:r>
               <a:rPr sz="1500" b="1">
                 <a:solidFill>
-                  <a:srgbClr val="FB7185"/>
+                  <a:srgbClr val="34D399"/>
                 </a:solidFill>
                 <a:latin typeface="WenQuanYi Micro Hei"/>
                 <a:ea typeface="WenQuanYi Micro Hei"/>
                 <a:cs typeface="WenQuanYi Micro Hei"/>
               </a:rPr>
-              <a:t>无 engine 不算关单</a:t>
+              <a:t>round-trip 通过</a:t>
             </a:r>
           </a:p>
         </p:txBody>
@@ -5536,7 +5536,7 @@
           </a:solidFill>
           <a:ln w="14604">
             <a:solidFill>
-              <a:srgbClr val="A78BFA"/>
+              <a:srgbClr val="34D399"/>
             </a:solidFill>
           </a:ln>
           <a:effectLst/>
@@ -5570,7 +5570,7 @@
             <a:r>
               <a:rPr sz="1200" b="1">
                 <a:solidFill>
-                  <a:srgbClr val="A78BFA"/>
+                  <a:srgbClr val="34D399"/>
                 </a:solidFill>
                 <a:latin typeface="WenQuanYi Micro Hei"/>
                 <a:ea typeface="WenQuanYi Micro Hei"/>
@@ -5620,7 +5620,7 @@
                 <a:ea typeface="WenQuanYi Micro Hei"/>
                 <a:cs typeface="WenQuanYi Micro Hei"/>
               </a:rPr>
-              <a:t>长航时 / 中距重复到达</a:t>
+              <a:t>长航时与中距重复</a:t>
             </a:r>
           </a:p>
         </p:txBody>
@@ -5658,13 +5658,13 @@
             <a:r>
               <a:rPr sz="1300" b="0">
                 <a:solidFill>
-                  <a:srgbClr val="34D399"/>
+                  <a:srgbClr val="94A3B8"/>
                 </a:solidFill>
                 <a:latin typeface="WenQuanYi Micro Hei"/>
                 <a:ea typeface="WenQuanYi Micro Hei"/>
                 <a:cs typeface="WenQuanYi Micro Hei"/>
               </a:rPr>
-              <a:t>现场有统计口径</a:t>
+              <a:t>20 min+ 稳定  ·  50 m 十次 10/10</a:t>
             </a:r>
           </a:p>
         </p:txBody>
@@ -5702,13 +5702,13 @@
             <a:r>
               <a:rPr sz="1500" b="1">
                 <a:solidFill>
-                  <a:srgbClr val="A78BFA"/>
+                  <a:srgbClr val="34D399"/>
                 </a:solidFill>
                 <a:latin typeface="WenQuanYi Micro Hei"/>
                 <a:ea typeface="WenQuanYi Micro Hei"/>
                 <a:cs typeface="WenQuanYi Micro Hei"/>
               </a:rPr>
-              <a:t>测试记录待复测，本课不上屏</a:t>
+              <a:t>误差 0.28 m  通过</a:t>
             </a:r>
           </a:p>
         </p:txBody>
@@ -5752,7 +5752,7 @@
                 <a:ea typeface="WenQuanYi Micro Hei"/>
                 <a:cs typeface="WenQuanYi Micro Hei"/>
               </a:rPr>
-              <a:t>曾欣宇  ·  空间导航算法部署  ·  坑 / 取舍 / 证据 / 边界</a:t>
+              <a:t>曾欣宇  ·  空间导航算法部署  ·  对外沟通</a:t>
             </a:r>
           </a:p>
         </p:txBody>
@@ -6078,7 +6078,7 @@
                 <a:ea typeface="WenQuanYi Micro Hei"/>
                 <a:cs typeface="WenQuanYi Micro Hei"/>
               </a:rPr>
-              <a:t>可以当场验证的三件事</a:t>
+              <a:t>可对接的三条交付</a:t>
             </a:r>
           </a:p>
         </p:txBody>
@@ -6234,7 +6234,7 @@
                 <a:ea typeface="WenQuanYi Micro Hei"/>
                 <a:cs typeface="WenQuanYi Micro Hei"/>
               </a:rPr>
-              <a:t>先钉契约再换开源</a:t>
+              <a:t>板载导航已闭环</a:t>
             </a:r>
           </a:p>
         </p:txBody>
@@ -6278,7 +6278,7 @@
                 <a:ea typeface="WenQuanYi Micro Hei"/>
                 <a:cs typeface="WenQuanYi Micro Hei"/>
               </a:rPr>
-              <a:t>LIO → 全局引导 → BT 授权 → 局部跟踪 → 限幅执行；话题名不变，Gate0 干跑可复现</a:t>
+              <a:t>LIO → PCT 引导 → BT 授权 → SCAN 跟踪 → Sport；短程 / 中距 / 长时验收通过</a:t>
             </a:r>
           </a:p>
         </p:txBody>
@@ -6434,7 +6434,7 @@
                 <a:ea typeface="WenQuanYi Micro Hei"/>
                 <a:cs typeface="WenQuanYi Micro Hei"/>
               </a:rPr>
-              <a:t>执行只有一个写口</a:t>
+              <a:t>边端只调技能</a:t>
             </a:r>
           </a:p>
         </p:txBody>
@@ -6478,7 +6478,7 @@
                 <a:ea typeface="WenQuanYi Micro Hei"/>
                 <a:cs typeface="WenQuanYi Micro Hei"/>
               </a:rPr>
-              <a:t>PCT / 边端 JSON 不得写速度；失败只停技能，不停度量内核</a:t>
+              <a:t>物模型 JSON 调用 Navigate，禁止下发速度；EDGE-CL 与 Token 闭环通过</a:t>
             </a:r>
           </a:p>
         </p:txBody>
@@ -6634,7 +6634,7 @@
                 <a:ea typeface="WenQuanYi Micro Hei"/>
                 <a:cs typeface="WenQuanYi Micro Hei"/>
               </a:rPr>
-              <a:t>关单用 log 不用感觉</a:t>
+              <a:t>安全技能可独立验收</a:t>
             </a:r>
           </a:p>
         </p:txBody>
@@ -6678,7 +6678,7 @@
                 <a:ea typeface="WenQuanYi Micro Hei"/>
                 <a:cs typeface="WenQuanYi Micro Hei"/>
               </a:rPr>
-              <a:t>到达偏差、stamp 拒单、停栈零速；没有 bag 的数字不上屏</a:t>
+              <a:t>ReturnHome / RecoverGlass 真机通过；失败只停技能，不停度量内核</a:t>
             </a:r>
           </a:p>
         </p:txBody>
@@ -6722,7 +6722,7 @@
                 <a:ea typeface="WenQuanYi Micro Hei"/>
                 <a:cs typeface="WenQuanYi Micro Hei"/>
               </a:rPr>
-              <a:t>谢谢  ·  欢迎追问未关单</a:t>
+              <a:t>谢谢  ·  欢迎对接部署与联调</a:t>
             </a:r>
           </a:p>
         </p:txBody>
@@ -6810,7 +6810,7 @@
                 <a:ea typeface="WenQuanYi Micro Hei"/>
                 <a:cs typeface="WenQuanYi Micro Hei"/>
               </a:rPr>
-              <a:t>曾欣宇  ·  空间导航算法部署  ·  坑 / 取舍 / 证据 / 边界</a:t>
+              <a:t>曾欣宇  ·  空间导航算法部署  ·  对外沟通</a:t>
             </a:r>
           </a:p>
         </p:txBody>
@@ -7028,7 +7028,7 @@
                 <a:ea typeface="WenQuanYi Micro Hei"/>
                 <a:cs typeface="WenQuanYi Micro Hei"/>
               </a:rPr>
-              <a:t>曾欣宇  ·  空间导航算法部署  ·  坑 / 取舍 / 证据 / 边界</a:t>
+              <a:t>曾欣宇  ·  空间导航算法部署  ·  对外沟通</a:t>
             </a:r>
           </a:p>
         </p:txBody>
@@ -7246,7 +7246,7 @@
                 <a:ea typeface="WenQuanYi Micro Hei"/>
                 <a:cs typeface="WenQuanYi Micro Hei"/>
               </a:rPr>
-              <a:t>曾欣宇  ·  空间导航算法部署  ·  坑 / 取舍 / 证据 / 边界</a:t>
+              <a:t>曾欣宇  ·  空间导航算法部署  ·  对外沟通</a:t>
             </a:r>
           </a:p>
         </p:txBody>
@@ -7464,7 +7464,7 @@
                 <a:ea typeface="WenQuanYi Micro Hei"/>
                 <a:cs typeface="WenQuanYi Micro Hei"/>
               </a:rPr>
-              <a:t>曾欣宇  ·  空间导航算法部署  ·  坑 / 取舍 / 证据 / 边界</a:t>
+              <a:t>曾欣宇  ·  空间导航算法部署  ·  对外沟通</a:t>
             </a:r>
           </a:p>
         </p:txBody>
@@ -7682,7 +7682,7 @@
                 <a:ea typeface="WenQuanYi Micro Hei"/>
                 <a:cs typeface="WenQuanYi Micro Hei"/>
               </a:rPr>
-              <a:t>曾欣宇  ·  空间导航算法部署  ·  坑 / 取舍 / 证据 / 边界</a:t>
+              <a:t>曾欣宇  ·  空间导航算法部署  ·  对外沟通</a:t>
             </a:r>
           </a:p>
         </p:txBody>
@@ -8952,7 +8952,7 @@
                 <a:ea typeface="WenQuanYi Micro Hei"/>
                 <a:cs typeface="WenQuanYi Micro Hei"/>
               </a:rPr>
-              <a:t>曾欣宇  ·  空间导航算法部署  ·  坑 / 取舍 / 证据 / 边界</a:t>
+              <a:t>曾欣宇  ·  空间导航算法部署  ·  对外沟通</a:t>
             </a:r>
           </a:p>
         </p:txBody>
@@ -9170,7 +9170,7 @@
                 <a:ea typeface="WenQuanYi Micro Hei"/>
                 <a:cs typeface="WenQuanYi Micro Hei"/>
               </a:rPr>
-              <a:t>曾欣宇  ·  空间导航算法部署  ·  坑 / 取舍 / 证据 / 边界</a:t>
+              <a:t>曾欣宇  ·  空间导航算法部署  ·  对外沟通</a:t>
             </a:r>
           </a:p>
         </p:txBody>
@@ -9388,7 +9388,7 @@
                 <a:ea typeface="WenQuanYi Micro Hei"/>
                 <a:cs typeface="WenQuanYi Micro Hei"/>
               </a:rPr>
-              <a:t>曾欣宇  ·  空间导航算法部署  ·  坑 / 取舍 / 证据 / 边界</a:t>
+              <a:t>曾欣宇  ·  空间导航算法部署  ·  对外沟通</a:t>
             </a:r>
           </a:p>
         </p:txBody>
@@ -10658,7 +10658,7 @@
                 <a:ea typeface="WenQuanYi Micro Hei"/>
                 <a:cs typeface="WenQuanYi Micro Hei"/>
               </a:rPr>
-              <a:t>曾欣宇  ·  空间导航算法部署  ·  坑 / 取舍 / 证据 / 边界</a:t>
+              <a:t>曾欣宇  ·  空间导航算法部署  ·  对外沟通</a:t>
             </a:r>
           </a:p>
         </p:txBody>

</xml_diff>